<commit_message>
Update PPTX: Add card background blocks, red accent borders, and phase badge matching PNG layout
</commit_message>
<xml_diff>
--- a/slide_esquadro.pptx
+++ b/slide_esquadro.pptx
@@ -3104,8 +3104,8 @@
         </p:nvSpPr>
         <p:spPr>
           <a:xfrm>
-            <a:off x="731520" y="457200"/>
-            <a:ext cx="7315200" cy="457200"/>
+            <a:off x="548640" y="457200"/>
+            <a:ext cx="7315200" cy="365760"/>
           </a:xfrm>
           <a:prstGeom prst="rect">
             <a:avLst/>
@@ -3119,7 +3119,7 @@
           <a:lstStyle/>
           <a:p>
             <a:pPr>
-              <a:defRPr sz="1200" b="1">
+              <a:defRPr sz="1100" b="1">
                 <a:solidFill>
                   <a:srgbClr val="C5C0B6"/>
                 </a:solidFill>
@@ -3134,14 +3134,67 @@
       </p:sp>
       <p:sp>
         <p:nvSpPr>
-          <p:cNvPr id="3" name="TextBox 2"/>
+          <p:cNvPr id="3" name="Rounded Rectangle 2"/>
+          <p:cNvSpPr/>
+          <p:nvPr/>
+        </p:nvSpPr>
+        <p:spPr>
+          <a:xfrm>
+            <a:off x="9326880" y="411480"/>
+            <a:ext cx="2286000" cy="365760"/>
+          </a:xfrm>
+          <a:prstGeom prst="roundRect">
+            <a:avLst/>
+          </a:prstGeom>
+          <a:solidFill>
+            <a:srgbClr val="E61C00"/>
+          </a:solidFill>
+          <a:ln>
+            <a:noFill/>
+          </a:ln>
+        </p:spPr>
+        <p:style>
+          <a:lnRef idx="1">
+            <a:schemeClr val="accent1"/>
+          </a:lnRef>
+          <a:fillRef idx="3">
+            <a:schemeClr val="accent1"/>
+          </a:fillRef>
+          <a:effectRef idx="2">
+            <a:schemeClr val="accent1"/>
+          </a:effectRef>
+          <a:fontRef idx="minor">
+            <a:schemeClr val="lt1"/>
+          </a:fontRef>
+        </p:style>
+        <p:txBody>
+          <a:bodyPr rtlCol="0" anchor="ctr"/>
+          <a:lstStyle/>
+          <a:p>
+            <a:pPr algn="ctr">
+              <a:defRPr sz="1100" b="1">
+                <a:solidFill>
+                  <a:srgbClr val="FFFFFF"/>
+                </a:solidFill>
+                <a:latin typeface="IBM Plex Mono"/>
+              </a:defRPr>
+            </a:pPr>
+            <a:r>
+              <a:t>PREVISÃO: JAN / 2027</a:t>
+            </a:r>
+          </a:p>
+        </p:txBody>
+      </p:sp>
+      <p:sp>
+        <p:nvSpPr>
+          <p:cNvPr id="4" name="TextBox 3"/>
           <p:cNvSpPr txBox="1"/>
           <p:nvPr/>
         </p:nvSpPr>
         <p:spPr>
           <a:xfrm>
-            <a:off x="8686800" y="457200"/>
-            <a:ext cx="2743200" cy="457200"/>
+            <a:off x="548640" y="1371600"/>
+            <a:ext cx="3840480" cy="914400"/>
           </a:xfrm>
           <a:prstGeom prst="rect">
             <a:avLst/>
@@ -3154,30 +3207,30 @@
           </a:bodyPr>
           <a:lstStyle/>
           <a:p>
-            <a:pPr algn="r">
-              <a:defRPr sz="1200" b="1">
+            <a:pPr>
+              <a:defRPr sz="4800" b="1">
                 <a:solidFill>
-                  <a:srgbClr val="E61C00"/>
+                  <a:srgbClr val="FFFFFF"/>
                 </a:solidFill>
                 <a:latin typeface="IBM Plex Mono"/>
               </a:defRPr>
             </a:pPr>
             <a:r>
-              <a:t>PREVISÃO: JAN / 2027</a:t>
-            </a:r>
-          </a:p>
-        </p:txBody>
-      </p:sp>
-      <p:sp>
-        <p:nvSpPr>
-          <p:cNvPr id="4" name="TextBox 3"/>
+              <a:t>ESQUADЯO</a:t>
+            </a:r>
+          </a:p>
+        </p:txBody>
+      </p:sp>
+      <p:sp>
+        <p:nvSpPr>
+          <p:cNvPr id="5" name="TextBox 4"/>
           <p:cNvSpPr txBox="1"/>
           <p:nvPr/>
         </p:nvSpPr>
         <p:spPr>
           <a:xfrm>
-            <a:off x="731520" y="1645920"/>
-            <a:ext cx="3840480" cy="1097280"/>
+            <a:off x="548640" y="2468880"/>
+            <a:ext cx="3931920" cy="2011680"/>
           </a:xfrm>
           <a:prstGeom prst="rect">
             <a:avLst/>
@@ -3185,84 +3238,120 @@
           <a:noFill/>
         </p:spPr>
         <p:txBody>
-          <a:bodyPr wrap="none">
+          <a:bodyPr wrap="square">
             <a:spAutoFit/>
           </a:bodyPr>
           <a:lstStyle/>
           <a:p>
             <a:pPr>
-              <a:defRPr sz="4400" b="1">
+              <a:defRPr sz="1500">
                 <a:solidFill>
-                  <a:srgbClr val="FFFFFF"/>
+                  <a:srgbClr val="E5E3D9"/>
+                </a:solidFill>
+                <a:latin typeface="IBM Plex Sans"/>
+              </a:defRPr>
+            </a:pPr>
+            <a:r>
+              <a:t>Centralização das especificações técnicas no Illustrator, Photoshop, After Effects e Premiere. Automação de pranchetas e composições com réguas e safe zones oficiais.</a:t>
+            </a:r>
+          </a:p>
+        </p:txBody>
+      </p:sp>
+      <p:sp>
+        <p:nvSpPr>
+          <p:cNvPr id="6" name="Rounded Rectangle 5"/>
+          <p:cNvSpPr/>
+          <p:nvPr/>
+        </p:nvSpPr>
+        <p:spPr>
+          <a:xfrm>
+            <a:off x="548640" y="4663440"/>
+            <a:ext cx="3474720" cy="365760"/>
+          </a:xfrm>
+          <a:prstGeom prst="roundRect">
+            <a:avLst/>
+          </a:prstGeom>
+          <a:solidFill>
+            <a:srgbClr val="333333"/>
+          </a:solidFill>
+          <a:ln>
+            <a:solidFill>
+              <a:srgbClr val="555555"/>
+            </a:solidFill>
+          </a:ln>
+        </p:spPr>
+        <p:style>
+          <a:lnRef idx="1">
+            <a:schemeClr val="accent1"/>
+          </a:lnRef>
+          <a:fillRef idx="3">
+            <a:schemeClr val="accent1"/>
+          </a:fillRef>
+          <a:effectRef idx="2">
+            <a:schemeClr val="accent1"/>
+          </a:effectRef>
+          <a:fontRef idx="minor">
+            <a:schemeClr val="lt1"/>
+          </a:fontRef>
+        </p:style>
+        <p:txBody>
+          <a:bodyPr rtlCol="0" anchor="ctr"/>
+          <a:lstStyle/>
+          <a:p>
+            <a:pPr algn="ctr">
+              <a:defRPr sz="1100">
+                <a:solidFill>
+                  <a:srgbClr val="C5C0B6"/>
                 </a:solidFill>
                 <a:latin typeface="IBM Plex Mono"/>
               </a:defRPr>
             </a:pPr>
             <a:r>
-              <a:t>ESQUADЯO</a:t>
-            </a:r>
-          </a:p>
-        </p:txBody>
-      </p:sp>
-      <p:sp>
-        <p:nvSpPr>
-          <p:cNvPr id="5" name="TextBox 4"/>
-          <p:cNvSpPr txBox="1"/>
+              <a:t>Fase: Desenvolvimento &amp; Checagem</a:t>
+            </a:r>
+          </a:p>
+        </p:txBody>
+      </p:sp>
+      <p:sp>
+        <p:nvSpPr>
+          <p:cNvPr id="7" name="Rectangle 6"/>
+          <p:cNvSpPr/>
           <p:nvPr/>
         </p:nvSpPr>
         <p:spPr>
           <a:xfrm>
-            <a:off x="731520" y="2926080"/>
-            <a:ext cx="3840480" cy="2560320"/>
+            <a:off x="4663440" y="1371600"/>
+            <a:ext cx="3931920" cy="1097280"/>
           </a:xfrm>
           <a:prstGeom prst="rect">
             <a:avLst/>
           </a:prstGeom>
-          <a:noFill/>
+          <a:solidFill>
+            <a:srgbClr val="2A2A2A"/>
+          </a:solidFill>
+          <a:ln>
+            <a:noFill/>
+          </a:ln>
         </p:spPr>
-        <p:txBody>
-          <a:bodyPr wrap="square">
-            <a:spAutoFit/>
-          </a:bodyPr>
-          <a:lstStyle/>
-          <a:p>
-            <a:pPr>
-              <a:defRPr sz="1500">
-                <a:solidFill>
-                  <a:srgbClr val="C5C0B6"/>
-                </a:solidFill>
-                <a:latin typeface="IBM Plex Sans"/>
-              </a:defRPr>
-            </a:pPr>
-            <a:r>
-              <a:t>Centralização das especificações técnicas no Illustrator, Photoshop, After Effects e Premiere. Automação de pranchetas e composições com réguas e safe zones oficiais.</a:t>
-            </a:r>
-          </a:p>
-        </p:txBody>
-      </p:sp>
-      <p:sp>
-        <p:nvSpPr>
-          <p:cNvPr id="6" name="TextBox 5"/>
-          <p:cNvSpPr txBox="1"/>
-          <p:nvPr/>
-        </p:nvSpPr>
-        <p:spPr>
-          <a:xfrm>
-            <a:off x="4846320" y="1645920"/>
-            <a:ext cx="3840480" cy="1188720"/>
-          </a:xfrm>
-          <a:prstGeom prst="rect">
-            <a:avLst/>
-          </a:prstGeom>
-          <a:noFill/>
-        </p:spPr>
-        <p:txBody>
-          <a:bodyPr wrap="square">
-            <a:spAutoFit/>
-          </a:bodyPr>
-          <a:lstStyle/>
-          <a:p>
-            <a:pPr>
+        <p:style>
+          <a:lnRef idx="1">
+            <a:schemeClr val="accent1"/>
+          </a:lnRef>
+          <a:fillRef idx="3">
+            <a:schemeClr val="accent1"/>
+          </a:fillRef>
+          <a:effectRef idx="2">
+            <a:schemeClr val="accent1"/>
+          </a:effectRef>
+          <a:fontRef idx="minor">
+            <a:schemeClr val="lt1"/>
+          </a:fontRef>
+        </p:style>
+        <p:txBody>
+          <a:bodyPr rtlCol="0" anchor="ctr" wrap="square"/>
+          <a:lstStyle/>
+          <a:p>
+            <a:pPr algn="ctr">
               <a:defRPr sz="1200" b="1">
                 <a:solidFill>
                   <a:srgbClr val="FFFFFF"/>
@@ -3276,7 +3365,7 @@
           </a:p>
           <a:p>
             <a:pPr>
-              <a:defRPr sz="1300">
+              <a:defRPr sz="1200">
                 <a:solidFill>
                   <a:srgbClr val="C5C0B6"/>
                 </a:solidFill>
@@ -3291,27 +3380,87 @@
       </p:sp>
       <p:sp>
         <p:nvSpPr>
-          <p:cNvPr id="7" name="TextBox 6"/>
-          <p:cNvSpPr txBox="1"/>
+          <p:cNvPr id="8" name="Rectangle 7"/>
+          <p:cNvSpPr/>
           <p:nvPr/>
         </p:nvSpPr>
         <p:spPr>
           <a:xfrm>
-            <a:off x="4846320" y="3017520"/>
-            <a:ext cx="3840480" cy="1188720"/>
+            <a:off x="4663440" y="1371600"/>
+            <a:ext cx="73152" cy="1097280"/>
           </a:xfrm>
           <a:prstGeom prst="rect">
             <a:avLst/>
           </a:prstGeom>
-          <a:noFill/>
+          <a:solidFill>
+            <a:srgbClr val="E61C00"/>
+          </a:solidFill>
+          <a:ln>
+            <a:noFill/>
+          </a:ln>
         </p:spPr>
-        <p:txBody>
-          <a:bodyPr wrap="square">
-            <a:spAutoFit/>
-          </a:bodyPr>
-          <a:lstStyle/>
-          <a:p>
-            <a:pPr>
+        <p:style>
+          <a:lnRef idx="1">
+            <a:schemeClr val="accent1"/>
+          </a:lnRef>
+          <a:fillRef idx="3">
+            <a:schemeClr val="accent1"/>
+          </a:fillRef>
+          <a:effectRef idx="2">
+            <a:schemeClr val="accent1"/>
+          </a:effectRef>
+          <a:fontRef idx="minor">
+            <a:schemeClr val="lt1"/>
+          </a:fontRef>
+        </p:style>
+        <p:txBody>
+          <a:bodyPr rtlCol="0" anchor="ctr"/>
+          <a:lstStyle/>
+          <a:p>
+            <a:pPr algn="ctr"/>
+          </a:p>
+        </p:txBody>
+      </p:sp>
+      <p:sp>
+        <p:nvSpPr>
+          <p:cNvPr id="9" name="Rectangle 8"/>
+          <p:cNvSpPr/>
+          <p:nvPr/>
+        </p:nvSpPr>
+        <p:spPr>
+          <a:xfrm>
+            <a:off x="4663440" y="2606040"/>
+            <a:ext cx="3931920" cy="1097280"/>
+          </a:xfrm>
+          <a:prstGeom prst="rect">
+            <a:avLst/>
+          </a:prstGeom>
+          <a:solidFill>
+            <a:srgbClr val="2A2A2A"/>
+          </a:solidFill>
+          <a:ln>
+            <a:noFill/>
+          </a:ln>
+        </p:spPr>
+        <p:style>
+          <a:lnRef idx="1">
+            <a:schemeClr val="accent1"/>
+          </a:lnRef>
+          <a:fillRef idx="3">
+            <a:schemeClr val="accent1"/>
+          </a:fillRef>
+          <a:effectRef idx="2">
+            <a:schemeClr val="accent1"/>
+          </a:effectRef>
+          <a:fontRef idx="minor">
+            <a:schemeClr val="lt1"/>
+          </a:fontRef>
+        </p:style>
+        <p:txBody>
+          <a:bodyPr rtlCol="0" anchor="ctr" wrap="square"/>
+          <a:lstStyle/>
+          <a:p>
+            <a:pPr algn="ctr">
               <a:defRPr sz="1200" b="1">
                 <a:solidFill>
                   <a:srgbClr val="FFFFFF"/>
@@ -3325,7 +3474,7 @@
           </a:p>
           <a:p>
             <a:pPr>
-              <a:defRPr sz="1300">
+              <a:defRPr sz="1200">
                 <a:solidFill>
                   <a:srgbClr val="C5C0B6"/>
                 </a:solidFill>
@@ -3340,27 +3489,87 @@
       </p:sp>
       <p:sp>
         <p:nvSpPr>
-          <p:cNvPr id="8" name="TextBox 7"/>
-          <p:cNvSpPr txBox="1"/>
+          <p:cNvPr id="10" name="Rectangle 9"/>
+          <p:cNvSpPr/>
           <p:nvPr/>
         </p:nvSpPr>
         <p:spPr>
           <a:xfrm>
-            <a:off x="4846320" y="4389120"/>
-            <a:ext cx="3840480" cy="1188720"/>
+            <a:off x="4663440" y="2606040"/>
+            <a:ext cx="73152" cy="1097280"/>
           </a:xfrm>
           <a:prstGeom prst="rect">
             <a:avLst/>
           </a:prstGeom>
-          <a:noFill/>
+          <a:solidFill>
+            <a:srgbClr val="E61C00"/>
+          </a:solidFill>
+          <a:ln>
+            <a:noFill/>
+          </a:ln>
         </p:spPr>
-        <p:txBody>
-          <a:bodyPr wrap="square">
-            <a:spAutoFit/>
-          </a:bodyPr>
-          <a:lstStyle/>
-          <a:p>
-            <a:pPr>
+        <p:style>
+          <a:lnRef idx="1">
+            <a:schemeClr val="accent1"/>
+          </a:lnRef>
+          <a:fillRef idx="3">
+            <a:schemeClr val="accent1"/>
+          </a:fillRef>
+          <a:effectRef idx="2">
+            <a:schemeClr val="accent1"/>
+          </a:effectRef>
+          <a:fontRef idx="minor">
+            <a:schemeClr val="lt1"/>
+          </a:fontRef>
+        </p:style>
+        <p:txBody>
+          <a:bodyPr rtlCol="0" anchor="ctr"/>
+          <a:lstStyle/>
+          <a:p>
+            <a:pPr algn="ctr"/>
+          </a:p>
+        </p:txBody>
+      </p:sp>
+      <p:sp>
+        <p:nvSpPr>
+          <p:cNvPr id="11" name="Rectangle 10"/>
+          <p:cNvSpPr/>
+          <p:nvPr/>
+        </p:nvSpPr>
+        <p:spPr>
+          <a:xfrm>
+            <a:off x="4663440" y="3840480"/>
+            <a:ext cx="3931920" cy="1097280"/>
+          </a:xfrm>
+          <a:prstGeom prst="rect">
+            <a:avLst/>
+          </a:prstGeom>
+          <a:solidFill>
+            <a:srgbClr val="2A2A2A"/>
+          </a:solidFill>
+          <a:ln>
+            <a:noFill/>
+          </a:ln>
+        </p:spPr>
+        <p:style>
+          <a:lnRef idx="1">
+            <a:schemeClr val="accent1"/>
+          </a:lnRef>
+          <a:fillRef idx="3">
+            <a:schemeClr val="accent1"/>
+          </a:fillRef>
+          <a:effectRef idx="2">
+            <a:schemeClr val="accent1"/>
+          </a:effectRef>
+          <a:fontRef idx="minor">
+            <a:schemeClr val="lt1"/>
+          </a:fontRef>
+        </p:style>
+        <p:txBody>
+          <a:bodyPr rtlCol="0" anchor="ctr" wrap="square"/>
+          <a:lstStyle/>
+          <a:p>
+            <a:pPr algn="ctr">
               <a:defRPr sz="1200" b="1">
                 <a:solidFill>
                   <a:srgbClr val="FFFFFF"/>
@@ -3374,7 +3583,7 @@
           </a:p>
           <a:p>
             <a:pPr>
-              <a:defRPr sz="1300">
+              <a:defRPr sz="1200">
                 <a:solidFill>
                   <a:srgbClr val="C5C0B6"/>
                 </a:solidFill>
@@ -3387,9 +3596,52 @@
           </a:p>
         </p:txBody>
       </p:sp>
+      <p:sp>
+        <p:nvSpPr>
+          <p:cNvPr id="12" name="Rectangle 11"/>
+          <p:cNvSpPr/>
+          <p:nvPr/>
+        </p:nvSpPr>
+        <p:spPr>
+          <a:xfrm>
+            <a:off x="4663440" y="3840480"/>
+            <a:ext cx="73152" cy="1097280"/>
+          </a:xfrm>
+          <a:prstGeom prst="rect">
+            <a:avLst/>
+          </a:prstGeom>
+          <a:solidFill>
+            <a:srgbClr val="E61C00"/>
+          </a:solidFill>
+          <a:ln>
+            <a:noFill/>
+          </a:ln>
+        </p:spPr>
+        <p:style>
+          <a:lnRef idx="1">
+            <a:schemeClr val="accent1"/>
+          </a:lnRef>
+          <a:fillRef idx="3">
+            <a:schemeClr val="accent1"/>
+          </a:fillRef>
+          <a:effectRef idx="2">
+            <a:schemeClr val="accent1"/>
+          </a:effectRef>
+          <a:fontRef idx="minor">
+            <a:schemeClr val="lt1"/>
+          </a:fontRef>
+        </p:style>
+        <p:txBody>
+          <a:bodyPr rtlCol="0" anchor="ctr"/>
+          <a:lstStyle/>
+          <a:p>
+            <a:pPr algn="ctr"/>
+          </a:p>
+        </p:txBody>
+      </p:sp>
       <p:pic>
         <p:nvPicPr>
-          <p:cNvPr id="9" name="Picture 8" descr="demo.gif"/>
+          <p:cNvPr id="13" name="Picture 12" descr="demo.gif"/>
           <p:cNvPicPr>
             <a:picLocks noChangeAspect="1"/>
           </p:cNvPicPr>
@@ -3403,8 +3655,8 @@
         </p:blipFill>
         <p:spPr>
           <a:xfrm>
-            <a:off x="9144000" y="1645920"/>
-            <a:ext cx="2286000" cy="3657600"/>
+            <a:off x="8961120" y="1371600"/>
+            <a:ext cx="2651760" cy="4242816"/>
           </a:xfrm>
           <a:prstGeom prst="rect">
             <a:avLst/>
@@ -3413,14 +3665,14 @@
       </p:pic>
       <p:sp>
         <p:nvSpPr>
-          <p:cNvPr id="10" name="TextBox 9"/>
+          <p:cNvPr id="14" name="TextBox 13"/>
           <p:cNvSpPr txBox="1"/>
           <p:nvPr/>
         </p:nvSpPr>
         <p:spPr>
           <a:xfrm>
-            <a:off x="731520" y="6035040"/>
-            <a:ext cx="10698480" cy="457200"/>
+            <a:off x="548640" y="6126480"/>
+            <a:ext cx="10972800" cy="365760"/>
           </a:xfrm>
           <a:prstGeom prst="rect">
             <a:avLst/>
@@ -3434,7 +3686,7 @@
           <a:lstStyle/>
           <a:p>
             <a:pPr>
-              <a:defRPr sz="1100">
+              <a:defRPr sz="1000">
                 <a:solidFill>
                   <a:srgbClr val="C5C0B6"/>
                 </a:solidFill>

</xml_diff>

<commit_message>
Refine PPTX fonts and margins to align 1:1 with brand tokens
</commit_message>
<xml_diff>
--- a/slide_esquadro.pptx
+++ b/slide_esquadro.pptx
@@ -3104,7 +3104,7 @@
         </p:nvSpPr>
         <p:spPr>
           <a:xfrm>
-            <a:off x="548640" y="457200"/>
+            <a:off x="548640" y="365760"/>
             <a:ext cx="7315200" cy="365760"/>
           </a:xfrm>
           <a:prstGeom prst="rect">
@@ -3113,7 +3113,7 @@
           <a:noFill/>
         </p:spPr>
         <p:txBody>
-          <a:bodyPr wrap="none">
+          <a:bodyPr wrap="none" tIns="91440" bIns="91440">
             <a:spAutoFit/>
           </a:bodyPr>
           <a:lstStyle/>
@@ -3140,7 +3140,7 @@
         </p:nvSpPr>
         <p:spPr>
           <a:xfrm>
-            <a:off x="9326880" y="411480"/>
+            <a:off x="9326880" y="365760"/>
             <a:ext cx="2286000" cy="365760"/>
           </a:xfrm>
           <a:prstGeom prst="roundRect">
@@ -3193,8 +3193,8 @@
         </p:nvSpPr>
         <p:spPr>
           <a:xfrm>
-            <a:off x="548640" y="1371600"/>
-            <a:ext cx="3840480" cy="914400"/>
+            <a:off x="548640" y="1280160"/>
+            <a:ext cx="3931920" cy="822960"/>
           </a:xfrm>
           <a:prstGeom prst="rect">
             <a:avLst/>
@@ -3202,13 +3202,13 @@
           <a:noFill/>
         </p:spPr>
         <p:txBody>
-          <a:bodyPr wrap="none">
+          <a:bodyPr wrap="none" tIns="91440" bIns="91440">
             <a:spAutoFit/>
           </a:bodyPr>
           <a:lstStyle/>
           <a:p>
             <a:pPr>
-              <a:defRPr sz="4800" b="1">
+              <a:defRPr sz="4600" b="1">
                 <a:solidFill>
                   <a:srgbClr val="FFFFFF"/>
                 </a:solidFill>
@@ -3229,7 +3229,7 @@
         </p:nvSpPr>
         <p:spPr>
           <a:xfrm>
-            <a:off x="548640" y="2468880"/>
+            <a:off x="548640" y="2286000"/>
             <a:ext cx="3931920" cy="2011680"/>
           </a:xfrm>
           <a:prstGeom prst="rect">
@@ -3238,13 +3238,13 @@
           <a:noFill/>
         </p:spPr>
         <p:txBody>
-          <a:bodyPr wrap="square">
+          <a:bodyPr wrap="square" tIns="91440" bIns="91440">
             <a:spAutoFit/>
           </a:bodyPr>
           <a:lstStyle/>
           <a:p>
             <a:pPr>
-              <a:defRPr sz="1500">
+              <a:defRPr sz="1400">
                 <a:solidFill>
                   <a:srgbClr val="E5E3D9"/>
                 </a:solidFill>
@@ -3320,8 +3320,8 @@
         </p:nvSpPr>
         <p:spPr>
           <a:xfrm>
-            <a:off x="4663440" y="1371600"/>
-            <a:ext cx="3931920" cy="1097280"/>
+            <a:off x="4663440" y="1280160"/>
+            <a:ext cx="4023360" cy="1097280"/>
           </a:xfrm>
           <a:prstGeom prst="rect">
             <a:avLst/>
@@ -3348,7 +3348,7 @@
           </a:fontRef>
         </p:style>
         <p:txBody>
-          <a:bodyPr rtlCol="0" anchor="ctr" wrap="square"/>
+          <a:bodyPr rtlCol="0" anchor="ctr" wrap="square" tIns="91440" bIns="91440"/>
           <a:lstStyle/>
           <a:p>
             <a:pPr algn="ctr">
@@ -3386,7 +3386,7 @@
         </p:nvSpPr>
         <p:spPr>
           <a:xfrm>
-            <a:off x="4663440" y="1371600"/>
+            <a:off x="4663440" y="1280160"/>
             <a:ext cx="73152" cy="1097280"/>
           </a:xfrm>
           <a:prstGeom prst="rect">
@@ -3429,8 +3429,8 @@
         </p:nvSpPr>
         <p:spPr>
           <a:xfrm>
-            <a:off x="4663440" y="2606040"/>
-            <a:ext cx="3931920" cy="1097280"/>
+            <a:off x="4663440" y="2514600"/>
+            <a:ext cx="4023360" cy="1097280"/>
           </a:xfrm>
           <a:prstGeom prst="rect">
             <a:avLst/>
@@ -3457,7 +3457,7 @@
           </a:fontRef>
         </p:style>
         <p:txBody>
-          <a:bodyPr rtlCol="0" anchor="ctr" wrap="square"/>
+          <a:bodyPr rtlCol="0" anchor="ctr" wrap="square" tIns="91440" bIns="91440"/>
           <a:lstStyle/>
           <a:p>
             <a:pPr algn="ctr">
@@ -3495,7 +3495,7 @@
         </p:nvSpPr>
         <p:spPr>
           <a:xfrm>
-            <a:off x="4663440" y="2606040"/>
+            <a:off x="4663440" y="2514600"/>
             <a:ext cx="73152" cy="1097280"/>
           </a:xfrm>
           <a:prstGeom prst="rect">
@@ -3538,8 +3538,8 @@
         </p:nvSpPr>
         <p:spPr>
           <a:xfrm>
-            <a:off x="4663440" y="3840480"/>
-            <a:ext cx="3931920" cy="1097280"/>
+            <a:off x="4663440" y="3749040"/>
+            <a:ext cx="4023360" cy="1097280"/>
           </a:xfrm>
           <a:prstGeom prst="rect">
             <a:avLst/>
@@ -3566,7 +3566,7 @@
           </a:fontRef>
         </p:style>
         <p:txBody>
-          <a:bodyPr rtlCol="0" anchor="ctr" wrap="square"/>
+          <a:bodyPr rtlCol="0" anchor="ctr" wrap="square" tIns="91440" bIns="91440"/>
           <a:lstStyle/>
           <a:p>
             <a:pPr algn="ctr">
@@ -3604,7 +3604,7 @@
         </p:nvSpPr>
         <p:spPr>
           <a:xfrm>
-            <a:off x="4663440" y="3840480"/>
+            <a:off x="4663440" y="3749040"/>
             <a:ext cx="73152" cy="1097280"/>
           </a:xfrm>
           <a:prstGeom prst="rect">
@@ -3655,7 +3655,7 @@
         </p:blipFill>
         <p:spPr>
           <a:xfrm>
-            <a:off x="8961120" y="1371600"/>
+            <a:off x="8961120" y="1280160"/>
             <a:ext cx="2651760" cy="4242816"/>
           </a:xfrm>
           <a:prstGeom prst="rect">
@@ -3680,7 +3680,7 @@
           <a:noFill/>
         </p:spPr>
         <p:txBody>
-          <a:bodyPr wrap="none">
+          <a:bodyPr wrap="none" tIns="91440" bIns="91440">
             <a:spAutoFit/>
           </a:bodyPr>
           <a:lstStyle/>

</xml_diff>